<commit_message>
Proofread mrcr-v2 slides page by page with Gemini
</commit_message>
<xml_diff>
--- a/slides/datasets-in-10-minutes-mrcr-v2.pptx
+++ b/slides/datasets-in-10-minutes-mrcr-v2.pptx
@@ -7216,7 +7216,7 @@
                 <a:ea typeface="Noto Sans CJK JP"/>
                 <a:cs typeface="Noto Sans"/>
               </a:rPr>
-              <a:t>長い会話の中で、似た依頼の順序をたどる
+              <a:t>長い会話の中で似た依頼の順序をたどり、
 指定された過去の応答を再掲する評価</a:t>
             </a:r>
           </a:p>
@@ -8460,7 +8460,7 @@
                 <a:ea typeface="Noto Sans CJK JP"/>
                 <a:cs typeface="Noto Sans"/>
               </a:rPr>
-              <a:t>「古代の神話」を題材にした、ユーモラスな文体のエッセイの1番目を再掲する。</a:t>
+              <a:t>要旨：「古代の神話」を題材にした、ユーモラスな文体のエッセイの1番目を再掲する。</a:t>
             </a:r>
           </a:p>
         </p:txBody>
@@ -10246,7 +10246,7 @@
                 <a:ea typeface="Noto Sans CJK JP"/>
                 <a:cs typeface="Noto Sans"/>
               </a:rPr>
-              <a:t>一致する依頼への応答を出現順に抜粋。太字が指定対象。</a:t>
+              <a:t>一致する依頼への応答を出現順に抜粋。</a:t>
             </a:r>
           </a:p>
         </p:txBody>
@@ -10613,7 +10613,7 @@
                 <a:ea typeface="Noto Sans CJK JP"/>
                 <a:cs typeface="Noto Sans"/>
               </a:rPr>
-              <a:t>「宇宙探査」を題材にした、改まった文体のエッセイの4番目を再掲する。</a:t>
+              <a:t>要旨：「宇宙探査」を題材にした、改まった文体の4番目のエッセイを再掲する。</a:t>
             </a:r>
           </a:p>
         </p:txBody>
@@ -16231,7 +16231,7 @@
                 <a:ea typeface="Noto Sans CJK JP"/>
                 <a:cs typeface="Noto Sans"/>
               </a:rPr>
-              <a:t>会話を長くする区間と、needle数を選べる</a:t>
+              <a:t>会話の長さの区間と、needle数を選べる</a:t>
             </a:r>
           </a:p>
         </p:txBody>
@@ -16812,7 +16812,7 @@
                           <a:ea typeface="Noto Sans CJK JP"/>
                           <a:cs typeface="Noto Sans"/>
                         </a:rPr>
-                        <a:t>1M、2M、4M、8Mに向かう区間を配布</a:t>
+                        <a:t>1M、2M、4M、8Mに至る区間を配布</a:t>
                       </a:r>
                     </a:p>
                   </a:txBody>
@@ -18025,7 +18025,7 @@
                 <a:ea typeface="Noto Sans CJK JP"/>
                 <a:cs typeface="Noto Sans"/>
               </a:rPr>
-              <a:t>長文の中で、似た依頼と順序を保って追えるか</a:t>
+              <a:t>長文の中で、似た依頼を順序通りに追えるか</a:t>
             </a:r>
           </a:p>
         </p:txBody>
@@ -19282,7 +19282,7 @@
                 <a:ea typeface="Noto Sans CJK JP"/>
                 <a:cs typeface="Noto Sans"/>
               </a:rPr>
-              <a:t>「ペンギン」を題材にした、技術的な文体のツイートの2番目を再掲する。</a:t>
+              <a:t>要旨：「ペンギン」を題材にした、技術的な文体のツイートの2番目を再掲する。</a:t>
             </a:r>
           </a:p>
         </p:txBody>
@@ -19801,7 +19801,7 @@
                 <a:ea typeface="Noto Sans CJK JP"/>
                 <a:cs typeface="Noto Sans"/>
               </a:rPr>
-              <a:t>「宇宙探査」を題材にした、古風な文体の詩の1番目を再掲する。</a:t>
+              <a:t>要旨：「宇宙探査」を題材にした、古風な文体の詩の1番目を再掲する。</a:t>
             </a:r>
           </a:p>
         </p:txBody>
@@ -20320,7 +20320,7 @@
                 <a:ea typeface="Noto Sans CJK JP"/>
                 <a:cs typeface="Noto Sans"/>
               </a:rPr>
-              <a:t>「フラミンゴ」を題材にした、くだけた文体のなぞなぞの1番目を再掲する。</a:t>
+              <a:t>要旨：「フラミンゴ」を題材にした、くだけた文体のなぞなぞの1番目を再掲する。</a:t>
             </a:r>
           </a:p>
         </p:txBody>
@@ -20839,7 +20839,7 @@
                 <a:ea typeface="Noto Sans CJK JP"/>
                 <a:cs typeface="Noto Sans"/>
               </a:rPr>
-              <a:t>「架空の製品発表」を題材にした、くだけた文体の詩の2番目を再掲する。</a:t>
+              <a:t>要旨：「架空の製品発表」を題材にした、くだけた文体の詩の2番目を再掲する。</a:t>
             </a:r>
           </a:p>
         </p:txBody>
@@ -21358,7 +21358,7 @@
                 <a:ea typeface="Noto Sans CJK JP"/>
                 <a:cs typeface="Noto Sans"/>
               </a:rPr>
-              <a:t>「園芸のコツ」を題材にした、古風な文体の短編小説の2番目を再掲する。</a:t>
+              <a:t>要旨：「園芸のコツ」を題材にした、古風な文体の短編小説の2番目を再掲する。</a:t>
             </a:r>
           </a:p>
         </p:txBody>
@@ -21877,7 +21877,7 @@
                 <a:ea typeface="Noto Sans CJK JP"/>
                 <a:cs typeface="Noto Sans"/>
               </a:rPr>
-              <a:t>「園芸のコツ」を題材にした、ユーモラスな文体の詩の1番目を再掲する。</a:t>
+              <a:t>要旨：「園芸のコツ」を題材にした、ユーモラスな文体の1番目の詩を再掲する。</a:t>
             </a:r>
           </a:p>
         </p:txBody>
@@ -22396,7 +22396,7 @@
                 <a:ea typeface="Noto Sans CJK JP"/>
                 <a:cs typeface="Noto Sans"/>
               </a:rPr>
-              <a:t>「ペンギン」を題材にした、ユーモラスな文体の詩の5番目を再掲する。</a:t>
+              <a:t>要旨：「ペンギン」を題材にした、ユーモラスな文体の詩の5番目を再掲する。</a:t>
             </a:r>
           </a:p>
         </p:txBody>
@@ -22915,7 +22915,7 @@
                 <a:ea typeface="Noto Sans CJK JP"/>
                 <a:cs typeface="Noto Sans"/>
               </a:rPr>
-              <a:t>「古代の神話」を題材にした、技術的な文体の短編小説の4番目を再掲する。</a:t>
+              <a:t>要旨：「古代の神話」を題材にした、技術的な文体の短編小説の4番目を再掲する。</a:t>
             </a:r>
           </a:p>
         </p:txBody>
@@ -23434,7 +23434,7 @@
                 <a:ea typeface="Noto Sans CJK JP"/>
                 <a:cs typeface="Noto Sans"/>
               </a:rPr>
-              <a:t>「架空の製品発表」を題材にした、改まった文体のブログ記事の2番目を再掲する。</a:t>
+              <a:t>要旨：「架空の製品発表」を題材にした、改まった文体のブログ記事の2番目を再掲する。</a:t>
             </a:r>
           </a:p>
         </p:txBody>
@@ -24067,7 +24067,7 @@
                 <a:ea typeface="Noto Sans CJK JP"/>
                 <a:cs typeface="Noto Sans"/>
               </a:rPr>
-              <a:t>「架空の製品発表」を題材にした、古風な文体のツイートの1番目を再掲する。</a:t>
+              <a:t>要旨：「架空の製品発表」を題材にした、古風な文体のツイートの1番目を再掲する。</a:t>
             </a:r>
           </a:p>
         </p:txBody>
@@ -25474,7 +25474,7 @@
                 <a:ea typeface="Noto Sans CJK JP"/>
                 <a:cs typeface="Noto Sans"/>
               </a:rPr>
-              <a:t>平均長はCSVのcontext_len（トークン）。会話は最終指示を除いて重複排除。</a:t>
+              <a:t>平均長はCSVのcontext_len（トークン）。会話は最終指示を除いて重複を排除。</a:t>
             </a:r>
           </a:p>
         </p:txBody>
@@ -27368,7 +27368,7 @@
                 <a:ea typeface="Noto Sans CJK JP"/>
                 <a:cs typeface="Noto Sans"/>
               </a:rPr>
-              <a:t>OpenAIも2025年に、別のMRCRデータをHugging Faceで公開している。こちらは、2025年12月に対象応答の数と正解の誤りを修正した。</a:t>
+              <a:t>OpenAIも2025年に、別のMRCRデータをHugging Faceで公開している。こちらは、2025年12月に対象応答の数と正解の誤りが修正された。</a:t>
             </a:r>
           </a:p>
           <a:p>
@@ -27733,7 +27733,7 @@
                 <a:ea typeface="Noto Sans CJK JP"/>
                 <a:cs typeface="Noto Sans"/>
               </a:rPr>
-              <a:t>本資料は最短の4K〜8K区間のCSV3本を取得した。より長い区間はdownload.shで選んで取得できる。</a:t>
+              <a:t>本資料では最短の4K〜8K区間のCSV3本を取得した。より長い区間はdownload.shで選んで取得できる。</a:t>
             </a:r>
           </a:p>
         </p:txBody>
@@ -28122,7 +28122,7 @@
                 <a:ea typeface="Noto Sans CJK JP"/>
                 <a:cs typeface="Noto Sans"/>
               </a:rPr>
-              <a:t>MRCRを説明したMichelangelo論文の第一著者はKiran Vodrahalli、最終著者はKate Olszewska。Google DeepMindとGoogle Researchの研究として2024年に公開された。</a:t>
+              <a:t>MRCRを提案したMichelangelo論文の第一著者はKiran Vodrahalli、最終著者はKate Olszewska。Google DeepMindとGoogle Researchの研究として2024年に公開された。</a:t>
             </a:r>
           </a:p>
           <a:p>
@@ -28182,7 +28182,7 @@
                 <a:ea typeface="Noto Sans CJK JP"/>
                 <a:cs typeface="Noto Sans"/>
               </a:rPr>
-              <a:t>公開v2はGoogle DeepMindのeval_hubに収録され、モデルカードの数値を再現するためのデータと評価コードを提供する。</a:t>
+              <a:t>公開版のv2はGoogle DeepMindのeval_hubに収録され、モデルカードの数値を再現するためのデータと評価コードを提供する。</a:t>
             </a:r>
           </a:p>
         </p:txBody>
@@ -29620,7 +29620,7 @@
                 <a:ea typeface="Noto Sans CJK JP"/>
                 <a:cs typeface="Noto Sans"/>
               </a:rPr>
-              <a:t>長文から一つの目印を探すだけの評価に対して、MRCRは似た依頼を複数置く。同じ題材でも、文章の形式や文体が異なる。</a:t>
+              <a:t>長文から一つの目印を探すだけの評価に対して、MRCR（Multi-round Coreference Resolution）は似た依頼を複数置く。同じ題材でも、文章の形式や文体が異なる。</a:t>
             </a:r>
           </a:p>
           <a:p>
@@ -29680,7 +29680,7 @@
                 <a:ea typeface="Noto Sans CJK JP"/>
                 <a:cs typeface="Noto Sans"/>
               </a:rPr>
-              <a:t>会話を長くしながら、同じ処理を続けられるかを調べる。MRCRはMulti-round Coreference Resolutionの略。</a:t>
+              <a:t>会話を長くしながら、同じ処理を続けられるかを調べる。</a:t>
             </a:r>
           </a:p>
         </p:txBody>
@@ -31060,7 +31060,7 @@
                 <a:ea typeface="Noto Sans CJK JP"/>
                 <a:cs typeface="Noto Sans"/>
               </a:rPr>
-              <a:t>「園芸のコツ」を題材にした、くだけた文体の短編小説の2番目を再掲する。</a:t>
+              <a:t>要旨：「園芸のコツ」を題材にした、くだけた文体の短編小説の2番目を再掲する。</a:t>
             </a:r>
           </a:p>
         </p:txBody>

</xml_diff>